<commit_message>
docs(repo): polish public competition repository
Add the repository URL to the official document and slide deck, improve the Portuguese project landing page, document reproducible slide generation, and remove local agent context from version control.
</commit_message>
<xml_diff>
--- a/docs/entrega/pitch/PITCH_AI_GLASSES_BRASIL.pptx
+++ b/docs/entrega/pitch/PITCH_AI_GLASSES_BRASIL.pptx
@@ -1847,7 +1847,7 @@
         </p:nvSpPr>
         <p:spPr>
           <a:xfrm>
-            <a:off x="685800" y="6291072"/>
+            <a:off x="685800" y="6181344"/>
             <a:ext cx="4206240" cy="228600"/>
           </a:xfrm>
           <a:prstGeom prst="rect">
@@ -1875,6 +1875,54 @@
               <a:t>Assistente de Prontuário Automático</a:t>
             </a:r>
             <a:endParaRPr lang="en-US" sz="900" dirty="0"/>
+          </a:p>
+        </p:txBody>
+      </p:sp>
+      <p:sp>
+        <p:nvSpPr>
+          <p:cNvPr id="12" name="Text 9">
+            <a:hlinkClick r:id="rId2" tooltip=""/>
+          </p:cNvPr>
+          <p:cNvSpPr/>
+          <p:nvPr/>
+        </p:nvSpPr>
+        <p:spPr>
+          <a:xfrm>
+            <a:off x="685800" y="6419088"/>
+            <a:ext cx="4480560" cy="164592"/>
+          </a:xfrm>
+          <a:prstGeom prst="rect">
+            <a:avLst/>
+          </a:prstGeom>
+          <a:noFill/>
+          <a:ln/>
+        </p:spPr>
+        <p:txBody>
+          <a:bodyPr wrap="square" lIns="0" tIns="0" rIns="0" bIns="0" rtlCol="0" anchor="ctr"/>
+          <a:lstStyle/>
+          <a:p>
+            <a:pPr indent="0" marL="0">
+              <a:buNone/>
+            </a:pPr>
+            <a:r>
+              <a:rPr lang="en-US" sz="750" u="sng" dirty="0">
+                <a:solidFill>
+                  <a:srgbClr val="C8E662"/>
+                </a:solidFill>
+                <a:latin typeface="Aptos" pitchFamily="34" charset="0"/>
+                <a:ea typeface="Aptos" pitchFamily="34" charset="-122"/>
+                <a:cs typeface="Aptos" pitchFamily="34" charset="-120"/>
+                <a:hlinkClick r:id="rId2" invalidUrl="" action="" tgtFrame="" tooltip="" history="1" highlightClick="0" endSnd="0">
+                  <a:extLst>
+                    <a:ext uri="{A12FA001-AC4F-418D-AE19-62706E023703}">
+                      <ahyp:hlinkClr xmlns:ahyp="http://schemas.microsoft.com/office/drawing/2018/hyperlinkcolor" val="tx"/>
+                    </a:ext>
+                  </a:extLst>
+                </a:hlinkClick>
+              </a:rPr>
+              <a:t>github.com/marcospaulo429/meta-glasses</a:t>
+            </a:r>
+            <a:endParaRPr lang="en-US" sz="750" dirty="0"/>
           </a:p>
         </p:txBody>
       </p:sp>
@@ -2603,7 +2651,7 @@
         <p:spPr>
           <a:xfrm>
             <a:off x="594360" y="6428232"/>
-            <a:ext cx="9875520" cy="164592"/>
+            <a:ext cx="5394960" cy="164592"/>
           </a:xfrm>
           <a:prstGeom prst="rect">
             <a:avLst/>
@@ -2628,6 +2676,54 @@
                 <a:cs typeface="Aptos" pitchFamily="34" charset="-120"/>
               </a:rPr>
               <a:t>Assistente de Prontuário Automático · AI Glasses Brasil 2026</a:t>
+            </a:r>
+            <a:endParaRPr lang="en-US" sz="750" dirty="0"/>
+          </a:p>
+        </p:txBody>
+      </p:sp>
+      <p:sp>
+        <p:nvSpPr>
+          <p:cNvPr id="22" name="Text 20">
+            <a:hlinkClick r:id="rId1" tooltip=""/>
+          </p:cNvPr>
+          <p:cNvSpPr/>
+          <p:nvPr/>
+        </p:nvSpPr>
+        <p:spPr>
+          <a:xfrm>
+            <a:off x="6080760" y="6428232"/>
+            <a:ext cx="4983480" cy="164592"/>
+          </a:xfrm>
+          <a:prstGeom prst="rect">
+            <a:avLst/>
+          </a:prstGeom>
+          <a:noFill/>
+          <a:ln/>
+        </p:spPr>
+        <p:txBody>
+          <a:bodyPr wrap="square" lIns="0" tIns="0" rIns="0" bIns="0" rtlCol="0" anchor="ctr"/>
+          <a:lstStyle/>
+          <a:p>
+            <a:pPr algn="r" indent="0" marL="0">
+              <a:buNone/>
+            </a:pPr>
+            <a:r>
+              <a:rPr lang="en-US" sz="750" u="sng" dirty="0">
+                <a:solidFill>
+                  <a:srgbClr val="0E604B"/>
+                </a:solidFill>
+                <a:latin typeface="Aptos" pitchFamily="34" charset="0"/>
+                <a:ea typeface="Aptos" pitchFamily="34" charset="-122"/>
+                <a:cs typeface="Aptos" pitchFamily="34" charset="-120"/>
+                <a:hlinkClick r:id="rId1" invalidUrl="" action="" tgtFrame="" tooltip="" history="1" highlightClick="0" endSnd="0">
+                  <a:extLst>
+                    <a:ext uri="{A12FA001-AC4F-418D-AE19-62706E023703}">
+                      <ahyp:hlinkClr xmlns:ahyp="http://schemas.microsoft.com/office/drawing/2018/hyperlinkcolor" val="tx"/>
+                    </a:ext>
+                  </a:extLst>
+                </a:hlinkClick>
+              </a:rPr>
+              <a:t>github.com/marcospaulo429/meta-glasses</a:t>
             </a:r>
             <a:endParaRPr lang="en-US" sz="750" dirty="0"/>
           </a:p>
@@ -3424,7 +3520,7 @@
         <p:spPr>
           <a:xfrm>
             <a:off x="594360" y="6428232"/>
-            <a:ext cx="9875520" cy="164592"/>
+            <a:ext cx="5394960" cy="164592"/>
           </a:xfrm>
           <a:prstGeom prst="rect">
             <a:avLst/>
@@ -3449,6 +3545,54 @@
                 <a:cs typeface="Aptos" pitchFamily="34" charset="-120"/>
               </a:rPr>
               <a:t>Assistente de Prontuário Automático · AI Glasses Brasil 2026</a:t>
+            </a:r>
+            <a:endParaRPr lang="en-US" sz="750" dirty="0"/>
+          </a:p>
+        </p:txBody>
+      </p:sp>
+      <p:sp>
+        <p:nvSpPr>
+          <p:cNvPr id="23" name="Text 21">
+            <a:hlinkClick r:id="rId1" tooltip=""/>
+          </p:cNvPr>
+          <p:cNvSpPr/>
+          <p:nvPr/>
+        </p:nvSpPr>
+        <p:spPr>
+          <a:xfrm>
+            <a:off x="6080760" y="6428232"/>
+            <a:ext cx="4983480" cy="164592"/>
+          </a:xfrm>
+          <a:prstGeom prst="rect">
+            <a:avLst/>
+          </a:prstGeom>
+          <a:noFill/>
+          <a:ln/>
+        </p:spPr>
+        <p:txBody>
+          <a:bodyPr wrap="square" lIns="0" tIns="0" rIns="0" bIns="0" rtlCol="0" anchor="ctr"/>
+          <a:lstStyle/>
+          <a:p>
+            <a:pPr algn="r" indent="0" marL="0">
+              <a:buNone/>
+            </a:pPr>
+            <a:r>
+              <a:rPr lang="en-US" sz="750" u="sng" dirty="0">
+                <a:solidFill>
+                  <a:srgbClr val="0E604B"/>
+                </a:solidFill>
+                <a:latin typeface="Aptos" pitchFamily="34" charset="0"/>
+                <a:ea typeface="Aptos" pitchFamily="34" charset="-122"/>
+                <a:cs typeface="Aptos" pitchFamily="34" charset="-120"/>
+                <a:hlinkClick r:id="rId1" invalidUrl="" action="" tgtFrame="" tooltip="" history="1" highlightClick="0" endSnd="0">
+                  <a:extLst>
+                    <a:ext uri="{A12FA001-AC4F-418D-AE19-62706E023703}">
+                      <ahyp:hlinkClr xmlns:ahyp="http://schemas.microsoft.com/office/drawing/2018/hyperlinkcolor" val="tx"/>
+                    </a:ext>
+                  </a:extLst>
+                </a:hlinkClick>
+              </a:rPr>
+              <a:t>github.com/marcospaulo429/meta-glasses</a:t>
             </a:r>
             <a:endParaRPr lang="en-US" sz="750" dirty="0"/>
           </a:p>
@@ -4664,7 +4808,7 @@
         <p:spPr>
           <a:xfrm>
             <a:off x="594360" y="6428232"/>
-            <a:ext cx="9875520" cy="164592"/>
+            <a:ext cx="5394960" cy="164592"/>
           </a:xfrm>
           <a:prstGeom prst="rect">
             <a:avLst/>
@@ -4689,6 +4833,54 @@
                 <a:cs typeface="Aptos" pitchFamily="34" charset="-120"/>
               </a:rPr>
               <a:t>Assistente de Prontuário Automático · AI Glasses Brasil 2026</a:t>
+            </a:r>
+            <a:endParaRPr lang="en-US" sz="750" dirty="0"/>
+          </a:p>
+        </p:txBody>
+      </p:sp>
+      <p:sp>
+        <p:nvSpPr>
+          <p:cNvPr id="37" name="Text 35">
+            <a:hlinkClick r:id="rId1" tooltip=""/>
+          </p:cNvPr>
+          <p:cNvSpPr/>
+          <p:nvPr/>
+        </p:nvSpPr>
+        <p:spPr>
+          <a:xfrm>
+            <a:off x="6080760" y="6428232"/>
+            <a:ext cx="4983480" cy="164592"/>
+          </a:xfrm>
+          <a:prstGeom prst="rect">
+            <a:avLst/>
+          </a:prstGeom>
+          <a:noFill/>
+          <a:ln/>
+        </p:spPr>
+        <p:txBody>
+          <a:bodyPr wrap="square" lIns="0" tIns="0" rIns="0" bIns="0" rtlCol="0" anchor="ctr"/>
+          <a:lstStyle/>
+          <a:p>
+            <a:pPr algn="r" indent="0" marL="0">
+              <a:buNone/>
+            </a:pPr>
+            <a:r>
+              <a:rPr lang="en-US" sz="750" u="sng" dirty="0">
+                <a:solidFill>
+                  <a:srgbClr val="0E604B"/>
+                </a:solidFill>
+                <a:latin typeface="Aptos" pitchFamily="34" charset="0"/>
+                <a:ea typeface="Aptos" pitchFamily="34" charset="-122"/>
+                <a:cs typeface="Aptos" pitchFamily="34" charset="-120"/>
+                <a:hlinkClick r:id="rId1" invalidUrl="" action="" tgtFrame="" tooltip="" history="1" highlightClick="0" endSnd="0">
+                  <a:extLst>
+                    <a:ext uri="{A12FA001-AC4F-418D-AE19-62706E023703}">
+                      <ahyp:hlinkClr xmlns:ahyp="http://schemas.microsoft.com/office/drawing/2018/hyperlinkcolor" val="tx"/>
+                    </a:ext>
+                  </a:extLst>
+                </a:hlinkClick>
+              </a:rPr>
+              <a:t>github.com/marcospaulo429/meta-glasses</a:t>
             </a:r>
             <a:endParaRPr lang="en-US" sz="750" dirty="0"/>
           </a:p>
@@ -5772,7 +5964,7 @@
         <p:spPr>
           <a:xfrm>
             <a:off x="594360" y="6428232"/>
-            <a:ext cx="9875520" cy="164592"/>
+            <a:ext cx="5394960" cy="164592"/>
           </a:xfrm>
           <a:prstGeom prst="rect">
             <a:avLst/>
@@ -5797,6 +5989,54 @@
                 <a:cs typeface="Aptos" pitchFamily="34" charset="-120"/>
               </a:rPr>
               <a:t>Fluxo completo entregue em arquitetura.png + arquitetura.mmd</a:t>
+            </a:r>
+            <a:endParaRPr lang="en-US" sz="750" dirty="0"/>
+          </a:p>
+        </p:txBody>
+      </p:sp>
+      <p:sp>
+        <p:nvSpPr>
+          <p:cNvPr id="33" name="Text 31">
+            <a:hlinkClick r:id="rId1" tooltip=""/>
+          </p:cNvPr>
+          <p:cNvSpPr/>
+          <p:nvPr/>
+        </p:nvSpPr>
+        <p:spPr>
+          <a:xfrm>
+            <a:off x="6080760" y="6428232"/>
+            <a:ext cx="4983480" cy="164592"/>
+          </a:xfrm>
+          <a:prstGeom prst="rect">
+            <a:avLst/>
+          </a:prstGeom>
+          <a:noFill/>
+          <a:ln/>
+        </p:spPr>
+        <p:txBody>
+          <a:bodyPr wrap="square" lIns="0" tIns="0" rIns="0" bIns="0" rtlCol="0" anchor="ctr"/>
+          <a:lstStyle/>
+          <a:p>
+            <a:pPr algn="r" indent="0" marL="0">
+              <a:buNone/>
+            </a:pPr>
+            <a:r>
+              <a:rPr lang="en-US" sz="750" u="sng" dirty="0">
+                <a:solidFill>
+                  <a:srgbClr val="0E604B"/>
+                </a:solidFill>
+                <a:latin typeface="Aptos" pitchFamily="34" charset="0"/>
+                <a:ea typeface="Aptos" pitchFamily="34" charset="-122"/>
+                <a:cs typeface="Aptos" pitchFamily="34" charset="-120"/>
+                <a:hlinkClick r:id="rId1" invalidUrl="" action="" tgtFrame="" tooltip="" history="1" highlightClick="0" endSnd="0">
+                  <a:extLst>
+                    <a:ext uri="{A12FA001-AC4F-418D-AE19-62706E023703}">
+                      <ahyp:hlinkClr xmlns:ahyp="http://schemas.microsoft.com/office/drawing/2018/hyperlinkcolor" val="tx"/>
+                    </a:ext>
+                  </a:extLst>
+                </a:hlinkClick>
+              </a:rPr>
+              <a:t>github.com/marcospaulo429/meta-glasses</a:t>
             </a:r>
             <a:endParaRPr lang="en-US" sz="750" dirty="0"/>
           </a:p>
@@ -6700,7 +6940,7 @@
         <p:spPr>
           <a:xfrm>
             <a:off x="594360" y="6428232"/>
-            <a:ext cx="9875520" cy="164592"/>
+            <a:ext cx="5394960" cy="164592"/>
           </a:xfrm>
           <a:prstGeom prst="rect">
             <a:avLst/>
@@ -6725,6 +6965,54 @@
                 <a:cs typeface="Aptos" pitchFamily="34" charset="-120"/>
               </a:rPr>
               <a:t>Assistente de Prontuário Automático · AI Glasses Brasil 2026</a:t>
+            </a:r>
+            <a:endParaRPr lang="en-US" sz="750" dirty="0"/>
+          </a:p>
+        </p:txBody>
+      </p:sp>
+      <p:sp>
+        <p:nvSpPr>
+          <p:cNvPr id="26" name="Text 24">
+            <a:hlinkClick r:id="rId1" tooltip=""/>
+          </p:cNvPr>
+          <p:cNvSpPr/>
+          <p:nvPr/>
+        </p:nvSpPr>
+        <p:spPr>
+          <a:xfrm>
+            <a:off x="6080760" y="6428232"/>
+            <a:ext cx="4983480" cy="164592"/>
+          </a:xfrm>
+          <a:prstGeom prst="rect">
+            <a:avLst/>
+          </a:prstGeom>
+          <a:noFill/>
+          <a:ln/>
+        </p:spPr>
+        <p:txBody>
+          <a:bodyPr wrap="square" lIns="0" tIns="0" rIns="0" bIns="0" rtlCol="0" anchor="ctr"/>
+          <a:lstStyle/>
+          <a:p>
+            <a:pPr algn="r" indent="0" marL="0">
+              <a:buNone/>
+            </a:pPr>
+            <a:r>
+              <a:rPr lang="en-US" sz="750" u="sng" dirty="0">
+                <a:solidFill>
+                  <a:srgbClr val="0E604B"/>
+                </a:solidFill>
+                <a:latin typeface="Aptos" pitchFamily="34" charset="0"/>
+                <a:ea typeface="Aptos" pitchFamily="34" charset="-122"/>
+                <a:cs typeface="Aptos" pitchFamily="34" charset="-120"/>
+                <a:hlinkClick r:id="rId1" invalidUrl="" action="" tgtFrame="" tooltip="" history="1" highlightClick="0" endSnd="0">
+                  <a:extLst>
+                    <a:ext uri="{A12FA001-AC4F-418D-AE19-62706E023703}">
+                      <ahyp:hlinkClr xmlns:ahyp="http://schemas.microsoft.com/office/drawing/2018/hyperlinkcolor" val="tx"/>
+                    </a:ext>
+                  </a:extLst>
+                </a:hlinkClick>
+              </a:rPr>
+              <a:t>github.com/marcospaulo429/meta-glasses</a:t>
             </a:r>
             <a:endParaRPr lang="en-US" sz="750" dirty="0"/>
           </a:p>

</xml_diff>

<commit_message>
docs(pitch): add approved clinician quote
Attribute the approved consultation-focused quote to Dr. Ranieri and present the remaining topics transparently as validation axes rather than interview findings.
</commit_message>
<xml_diff>
--- a/docs/entrega/pitch/PITCH_AI_GLASSES_BRASIL.pptx
+++ b/docs/entrega/pitch/PITCH_AI_GLASSES_BRASIL.pptx
@@ -598,8 +598,8 @@
             <a:r>
               <a:rPr lang="en-US" dirty="0"/>
               <a:t>Não queríamos assumir que um estudo internacional representava a rotina brasileira.
-Por isso conversamos com médicos reais.
-Substituir este trecho pelos achados e por uma citação verdadeira antes de gravar.</a:t>
+O Dr. Ranieri resumiu a tensão central: o prontuário deveria registrar a consulta, não interrompê-la.
+A próxima rodada de entrevistas mede tempo, contato visual, confiança e os principais receios.</a:t>
             </a:r>
             <a:endParaRPr lang="en-US" dirty="0"/>
           </a:p>
@@ -2064,7 +2064,7 @@
                 <a:ea typeface="Aptos" pitchFamily="34" charset="-122"/>
                 <a:cs typeface="Aptos" pitchFamily="34" charset="-120"/>
               </a:rPr>
-              <a:t>Substituir os campos destacados após ouvir médicos reais — sem inventar estatística.</a:t>
+              <a:t>Uma escuta inicial e quatro perguntas para orientar a validação com médicos.</a:t>
             </a:r>
             <a:endParaRPr lang="en-US" sz="1300" dirty="0"/>
           </a:p>
@@ -2169,7 +2169,7 @@
                 <a:ea typeface="Aptos Display" pitchFamily="34" charset="-122"/>
                 <a:cs typeface="Aptos Display" pitchFamily="34" charset="-120"/>
               </a:rPr>
-              <a:t>[INSERIR UMA FRASE REAL, CURTA E FORTE]</a:t>
+              <a:t>“O prontuário deveria registrar a consulta, não interrompê-la.”</a:t>
             </a:r>
             <a:endParaRPr lang="en-US" sz="2200" dirty="0"/>
           </a:p>
@@ -2208,7 +2208,7 @@
                 <a:ea typeface="Aptos" pitchFamily="34" charset="-122"/>
                 <a:cs typeface="Aptos" pitchFamily="34" charset="-120"/>
               </a:rPr>
-              <a:t>— Médico entrevistado · especialidade</a:t>
+              <a:t>— Dr. Ranieri · médico entrevistado</a:t>
             </a:r>
             <a:endParaRPr lang="en-US" sz="1000" dirty="0"/>
           </a:p>
@@ -2544,7 +2544,7 @@
         <p:spPr>
           <a:xfrm>
             <a:off x="7882128" y="3730752"/>
-            <a:ext cx="1298448" cy="384048"/>
+            <a:ext cx="1645920" cy="384048"/>
           </a:xfrm>
           <a:prstGeom prst="roundRect">
             <a:avLst>
@@ -2571,7 +2571,7 @@
         <p:spPr>
           <a:xfrm>
             <a:off x="7991856" y="3794760"/>
-            <a:ext cx="1078992" cy="201168"/>
+            <a:ext cx="1426464" cy="201168"/>
           </a:xfrm>
           <a:prstGeom prst="rect">
             <a:avLst/>
@@ -2597,7 +2597,7 @@
                 <a:ea typeface="Aptos" pitchFamily="34" charset="-122"/>
                 <a:cs typeface="Aptos" pitchFamily="34" charset="-120"/>
               </a:rPr>
-              <a:t>MAIOR RECEIO</a:t>
+              <a:t>EIXOS DE VALIDAÇÃO</a:t>
             </a:r>
             <a:endParaRPr lang="en-US" sz="1050" dirty="0"/>
           </a:p>
@@ -2636,7 +2636,7 @@
                 <a:ea typeface="Aptos Display" pitchFamily="34" charset="-122"/>
                 <a:cs typeface="Aptos Display" pitchFamily="34" charset="-120"/>
               </a:rPr>
-              <a:t>[precisão · privacidade · revisão · bateria]</a:t>
+              <a:t>Precisão · privacidade · revisão · bateria</a:t>
             </a:r>
             <a:endParaRPr lang="en-US" sz="1900" dirty="0"/>
           </a:p>

</xml_diff>

<commit_message>
docs(pitch): align deck with official workshop structure
Add the three-person team to the closing slide, clarify the three-minute narrative, simplify visible technical jargon, and regenerate the PDF, previews, and Canva assets.
</commit_message>
<xml_diff>
--- a/docs/entrega/pitch/PITCH_AI_GLASSES_BRASIL.pptx
+++ b/docs/entrega/pitch/PITCH_AI_GLASSES_BRASIL.pptx
@@ -690,7 +690,7 @@
               <a:t>Nossa proposta é um assistente de prontuário automático para Ray-Ban Meta.
 O médico conduz a consulta sem tocar em telas.
 O áudio é processado localmente no Android, fotos e atestados podem ser solicitados por voz e, ao final, o médico recebe um rascunho para revisar.
-A IA prepara; o médico decide.</a:t>
+A inteligência artificial prepara; o médico decide.</a:t>
             </a:r>
             <a:endParaRPr lang="en-US" dirty="0"/>
           </a:p>
@@ -963,6 +963,7 @@
               <a:rPr lang="en-US" dirty="0"/>
               <a:t>Já validamos o pipeline completo no emulador Android: áudio real, transcrição, foto por voz, SOAP, atestado, criptografia e revisão.
 São 52 testes automatizados.
+Nossa equipe reúne Lucas Pacheco em Android e front-end, Marcos Paulo em inteligência artificial e Lucas Isaac em inteligência artificial, privacidade e requisitos.
 No hackathon, nossa primeira hora será dedicada a validar o HFP, a câmera DAT e a autonomia no hardware real.
 Não queremos substituir o julgamento médico. Queremos devolver ao médico tempo e atenção para o paciente.</a:t>
             </a:r>
@@ -3169,7 +3170,7 @@
                 <a:ea typeface="Aptos" pitchFamily="34" charset="-122"/>
                 <a:cs typeface="Aptos" pitchFamily="34" charset="-120"/>
               </a:rPr>
-              <a:t>Prontuário SOAP processado localmente</a:t>
+              <a:t>Prontuário clínico processado localmente</a:t>
             </a:r>
             <a:endParaRPr lang="en-US" sz="1700" dirty="0"/>
           </a:p>
@@ -4172,7 +4173,7 @@
                 <a:ea typeface="Aptos" pitchFamily="34" charset="-122"/>
                 <a:cs typeface="Aptos" pitchFamily="34" charset="-120"/>
               </a:rPr>
-              <a:t>Áudio via HFP</a:t>
+              <a:t>Áudio pelos óculos</a:t>
             </a:r>
             <a:endParaRPr lang="en-US" sz="1150" dirty="0"/>
           </a:p>
@@ -4560,7 +4561,7 @@
                 <a:ea typeface="Aptos" pitchFamily="34" charset="-122"/>
                 <a:cs typeface="Aptos" pitchFamily="34" charset="-120"/>
               </a:rPr>
-              <a:t>SOAP local com proveniência</a:t>
+              <a:t>Prontuário com origem</a:t>
             </a:r>
             <a:endParaRPr lang="en-US" sz="1150" dirty="0"/>
           </a:p>
@@ -4793,7 +4794,7 @@
                 <a:ea typeface="Aptos" pitchFamily="34" charset="-122"/>
                 <a:cs typeface="Aptos" pitchFamily="34" charset="-120"/>
               </a:rPr>
-              <a:t>ASR não reconheceu um CID? O sistema omite o dado — não tenta adivinhar.</a:t>
+              <a:t>A transcrição falhou em um código clínico? O sistema omite — não tenta adivinhar.</a:t>
             </a:r>
             <a:endParaRPr lang="en-US" sz="1400" dirty="0"/>
           </a:p>
@@ -5033,7 +5034,7 @@
                 <a:ea typeface="Aptos Display" pitchFamily="34" charset="-122"/>
                 <a:cs typeface="Aptos Display" pitchFamily="34" charset="-120"/>
               </a:rPr>
-              <a:t>IA local. Médico no controle.</a:t>
+              <a:t>Inteligência local. Médico no controle.</a:t>
             </a:r>
             <a:endParaRPr lang="en-US" sz="3000" dirty="0"/>
           </a:p>
@@ -5175,7 +5176,7 @@
                 <a:ea typeface="Aptos" pitchFamily="34" charset="-122"/>
                 <a:cs typeface="Aptos" pitchFamily="34" charset="-120"/>
               </a:rPr>
-              <a:t>HFP + câmera DAT 0.9</a:t>
+              <a:t>Áudio + câmera Meta</a:t>
             </a:r>
             <a:endParaRPr lang="en-US" sz="1050" dirty="0"/>
           </a:p>
@@ -5392,7 +5393,7 @@
                 <a:ea typeface="Aptos Display" pitchFamily="34" charset="-122"/>
                 <a:cs typeface="Aptos Display" pitchFamily="34" charset="-120"/>
               </a:rPr>
-              <a:t>IA CLÍNICA</a:t>
+              <a:t>PIPELINE CLÍNICO</a:t>
             </a:r>
             <a:endParaRPr lang="en-US" sz="1700" dirty="0"/>
           </a:p>
@@ -5431,7 +5432,7 @@
                 <a:ea typeface="Aptos" pitchFamily="34" charset="-122"/>
                 <a:cs typeface="Aptos" pitchFamily="34" charset="-120"/>
               </a:rPr>
-              <a:t>Fatos + SOAP + origem</a:t>
+              <a:t>Fatos + prontuário + origem</a:t>
             </a:r>
             <a:endParaRPr lang="en-US" sz="1050" dirty="0"/>
           </a:p>
@@ -5648,7 +5649,7 @@
                 <a:ea typeface="Aptos Display" pitchFamily="34" charset="-122"/>
                 <a:cs typeface="Aptos Display" pitchFamily="34" charset="-120"/>
               </a:rPr>
-              <a:t>TTS</a:t>
+              <a:t>VOZ</a:t>
             </a:r>
             <a:endParaRPr lang="en-US" sz="1600" dirty="0"/>
           </a:p>
@@ -5819,7 +5820,7 @@
                 <a:ea typeface="Aptos" pitchFamily="34" charset="-122"/>
                 <a:cs typeface="Aptos" pitchFamily="34" charset="-120"/>
               </a:rPr>
-              <a:t>HFP indisponível → mic do telefone</a:t>
+              <a:t>Áudio dos óculos indisponível → mic do telefone</a:t>
             </a:r>
             <a:endParaRPr lang="en-US" sz="1700" dirty="0"/>
           </a:p>
@@ -5885,7 +5886,7 @@
                 <a:ea typeface="Aptos" pitchFamily="34" charset="-122"/>
                 <a:cs typeface="Aptos" pitchFamily="34" charset="-120"/>
               </a:rPr>
-              <a:t>ASR incerto → não informado, nunca inferido</a:t>
+              <a:t>Transcrição incerta → não informado, nunca inferido</a:t>
             </a:r>
             <a:endParaRPr lang="en-US" sz="1700" dirty="0"/>
           </a:p>
@@ -5949,7 +5950,7 @@
                 <a:ea typeface="Aptos" pitchFamily="34" charset="-122"/>
                 <a:cs typeface="Aptos" pitchFamily="34" charset="-120"/>
               </a:rPr>
-              <a:t>Sem IA em nuvem · retenção mínima · revisão humana</a:t>
+              <a:t>Sem inteligência em nuvem · retenção mínima · revisão humana</a:t>
             </a:r>
             <a:endParaRPr lang="en-US" sz="1200" dirty="0"/>
           </a:p>
@@ -6148,7 +6149,7 @@
                 <a:ea typeface="Aptos" pitchFamily="34" charset="-122"/>
                 <a:cs typeface="Aptos" pitchFamily="34" charset="-120"/>
               </a:rPr>
-              <a:t>EVIDÊNCIA E PRÓXIMOS PASSOS</a:t>
+              <a:t>EVIDÊNCIA, EQUIPE E PRÓXIMOS PASSOS</a:t>
             </a:r>
             <a:endParaRPr lang="en-US" sz="1000" dirty="0"/>
           </a:p>
@@ -6228,7 +6229,7 @@
                 <a:ea typeface="Aptos" pitchFamily="34" charset="-122"/>
                 <a:cs typeface="Aptos" pitchFamily="34" charset="-120"/>
               </a:rPr>
-              <a:t>O risco restante está concentrado e tem protocolo de validação.</a:t>
+              <a:t>Execução comprovada, competências complementares e um próximo teste objetivo.</a:t>
             </a:r>
             <a:endParaRPr lang="en-US" sz="1300" dirty="0"/>
           </a:p>
@@ -6243,7 +6244,7 @@
         <p:spPr>
           <a:xfrm>
             <a:off x="658368" y="1847088"/>
-            <a:ext cx="3200400" cy="3520440"/>
+            <a:ext cx="3200400" cy="2880360"/>
           </a:xfrm>
           <a:prstGeom prst="roundRect">
             <a:avLst/>
@@ -6267,8 +6268,8 @@
         </p:nvSpPr>
         <p:spPr>
           <a:xfrm>
-            <a:off x="1097280" y="2212848"/>
-            <a:ext cx="2331720" cy="960120"/>
+            <a:off x="1097280" y="2057400"/>
+            <a:ext cx="2331720" cy="868680"/>
           </a:xfrm>
           <a:prstGeom prst="rect">
             <a:avLst/>
@@ -6306,7 +6307,7 @@
         </p:nvSpPr>
         <p:spPr>
           <a:xfrm>
-            <a:off x="1051560" y="3200400"/>
+            <a:off x="1051560" y="2971800"/>
             <a:ext cx="2423160" cy="347472"/>
           </a:xfrm>
           <a:prstGeom prst="rect">
@@ -6345,8 +6346,8 @@
         </p:nvSpPr>
         <p:spPr>
           <a:xfrm>
-            <a:off x="960120" y="3886200"/>
-            <a:ext cx="2606040" cy="777240"/>
+            <a:off x="960120" y="3584448"/>
+            <a:ext cx="2606040" cy="658368"/>
           </a:xfrm>
           <a:prstGeom prst="rect">
             <a:avLst/>
@@ -6387,7 +6388,7 @@
                 <a:ea typeface="Aptos" pitchFamily="34" charset="-122"/>
                 <a:cs typeface="Aptos" pitchFamily="34" charset="-120"/>
               </a:rPr>
-              <a:t>SOAP · foto · atestado · cofre · revisão</a:t>
+              <a:t>prontuário · foto · atestado · cofre · revisão</a:t>
             </a:r>
             <a:endParaRPr lang="en-US" sz="1300" dirty="0"/>
           </a:p>
@@ -6492,7 +6493,7 @@
                 <a:ea typeface="Aptos" pitchFamily="34" charset="-122"/>
                 <a:cs typeface="Aptos" pitchFamily="34" charset="-120"/>
               </a:rPr>
-              <a:t>Captura HFP da voz do paciente</a:t>
+              <a:t>Captura da voz pelos óculos</a:t>
             </a:r>
             <a:endParaRPr lang="en-US" sz="1700" dirty="0"/>
           </a:p>
@@ -6558,7 +6559,7 @@
                 <a:ea typeface="Aptos" pitchFamily="34" charset="-122"/>
                 <a:cs typeface="Aptos" pitchFamily="34" charset="-120"/>
               </a:rPr>
-              <a:t>Burst de foto com DAT 0.9</a:t>
+              <a:t>Foto pontual com o toolkit Meta</a:t>
             </a:r>
             <a:endParaRPr lang="en-US" sz="1700" dirty="0"/>
           </a:p>
@@ -6869,24 +6870,61 @@
       </p:sp>
       <p:sp>
         <p:nvSpPr>
-          <p:cNvPr id="23" name="Shape 21"/>
-          <p:cNvSpPr/>
-          <p:nvPr/>
-        </p:nvSpPr>
-        <p:spPr>
-          <a:xfrm>
-            <a:off x="4407408" y="4892040"/>
-            <a:ext cx="6720840" cy="685800"/>
-          </a:xfrm>
-          <a:prstGeom prst="roundRect">
-            <a:avLst/>
-          </a:prstGeom>
-          <a:solidFill>
-            <a:srgbClr val="192321"/>
-          </a:solidFill>
-          <a:ln w="12700">
+          <p:cNvPr id="23" name="Text 21"/>
+          <p:cNvSpPr/>
+          <p:nvPr/>
+        </p:nvSpPr>
+        <p:spPr>
+          <a:xfrm>
+            <a:off x="685800" y="4965192"/>
+            <a:ext cx="914400" cy="228600"/>
+          </a:xfrm>
+          <a:prstGeom prst="rect">
+            <a:avLst/>
+          </a:prstGeom>
+          <a:noFill/>
+          <a:ln/>
+        </p:spPr>
+        <p:txBody>
+          <a:bodyPr wrap="square" lIns="0" tIns="0" rIns="0" bIns="0" rtlCol="0" anchor="ctr"/>
+          <a:lstStyle/>
+          <a:p>
+            <a:pPr indent="0" marL="0">
+              <a:buNone/>
+            </a:pPr>
+            <a:r>
+              <a:rPr lang="en-US" sz="1050" b="1" spc="110" kern="0" dirty="0">
+                <a:solidFill>
+                  <a:srgbClr val="0E604B"/>
+                </a:solidFill>
+                <a:latin typeface="Aptos" pitchFamily="34" charset="0"/>
+                <a:ea typeface="Aptos" pitchFamily="34" charset="-122"/>
+                <a:cs typeface="Aptos" pitchFamily="34" charset="-120"/>
+              </a:rPr>
+              <a:t>EQUIPE</a:t>
+            </a:r>
+            <a:endParaRPr lang="en-US" sz="1050" dirty="0"/>
+          </a:p>
+        </p:txBody>
+      </p:sp>
+      <p:sp>
+        <p:nvSpPr>
+          <p:cNvPr id="24" name="Shape 22"/>
+          <p:cNvSpPr/>
+          <p:nvPr/>
+        </p:nvSpPr>
+        <p:spPr>
+          <a:xfrm>
+            <a:off x="685800" y="5321808"/>
+            <a:ext cx="3337560" cy="0"/>
+          </a:xfrm>
+          <a:prstGeom prst="line">
+            <a:avLst/>
+          </a:prstGeom>
+          <a:noFill/>
+          <a:ln w="25400">
             <a:solidFill>
-              <a:srgbClr val="192321"/>
+              <a:srgbClr val="0E604B"/>
             </a:solidFill>
             <a:prstDash val="solid"/>
           </a:ln>
@@ -6894,69 +6932,73 @@
       </p:sp>
       <p:sp>
         <p:nvSpPr>
-          <p:cNvPr id="24" name="Text 22"/>
-          <p:cNvSpPr/>
-          <p:nvPr/>
-        </p:nvSpPr>
-        <p:spPr>
-          <a:xfrm>
-            <a:off x="4709160" y="5102352"/>
-            <a:ext cx="6126480" cy="246888"/>
-          </a:xfrm>
-          <a:prstGeom prst="rect">
-            <a:avLst/>
-          </a:prstGeom>
-          <a:noFill/>
-          <a:ln/>
-        </p:spPr>
-        <p:txBody>
-          <a:bodyPr wrap="square" lIns="0" tIns="0" rIns="0" bIns="0" rtlCol="0" anchor="ctr"/>
-          <a:lstStyle/>
-          <a:p>
-            <a:pPr algn="ctr" indent="0" marL="0">
-              <a:buNone/>
-            </a:pPr>
-            <a:r>
-              <a:rPr lang="en-US" sz="1800" b="1" dirty="0">
-                <a:solidFill>
-                  <a:srgbClr val="FFFFFF"/>
+          <p:cNvPr id="25" name="Text 23"/>
+          <p:cNvSpPr/>
+          <p:nvPr/>
+        </p:nvSpPr>
+        <p:spPr>
+          <a:xfrm>
+            <a:off x="685800" y="5468112"/>
+            <a:ext cx="3337560" cy="219456"/>
+          </a:xfrm>
+          <a:prstGeom prst="rect">
+            <a:avLst/>
+          </a:prstGeom>
+          <a:noFill/>
+          <a:ln/>
+        </p:spPr>
+        <p:txBody>
+          <a:bodyPr wrap="square" lIns="0" tIns="0" rIns="0" bIns="0" rtlCol="0" anchor="ctr">
+            <a:normAutofit/>
+          </a:bodyPr>
+          <a:lstStyle/>
+          <a:p>
+            <a:pPr indent="0" marL="0">
+              <a:buNone/>
+            </a:pPr>
+            <a:r>
+              <a:rPr lang="en-US" sz="1300" b="1" dirty="0">
+                <a:solidFill>
+                  <a:srgbClr val="192321"/>
                 </a:solidFill>
                 <a:latin typeface="Aptos Display" pitchFamily="34" charset="0"/>
                 <a:ea typeface="Aptos Display" pitchFamily="34" charset="-122"/>
                 <a:cs typeface="Aptos Display" pitchFamily="34" charset="-120"/>
               </a:rPr>
-              <a:t>Devolver ao médico tempo e atenção para o paciente.</a:t>
-            </a:r>
-            <a:endParaRPr lang="en-US" sz="1800" dirty="0"/>
-          </a:p>
-        </p:txBody>
-      </p:sp>
-      <p:sp>
-        <p:nvSpPr>
-          <p:cNvPr id="25" name="Text 23"/>
-          <p:cNvSpPr/>
-          <p:nvPr/>
-        </p:nvSpPr>
-        <p:spPr>
-          <a:xfrm>
-            <a:off x="594360" y="6428232"/>
-            <a:ext cx="5394960" cy="164592"/>
-          </a:xfrm>
-          <a:prstGeom prst="rect">
-            <a:avLst/>
-          </a:prstGeom>
-          <a:noFill/>
-          <a:ln/>
-        </p:spPr>
-        <p:txBody>
-          <a:bodyPr wrap="square" lIns="0" tIns="0" rIns="0" bIns="0" rtlCol="0" anchor="ctr"/>
+              <a:t>LUCAS PACHECO</a:t>
+            </a:r>
+            <a:endParaRPr lang="en-US" sz="1300" dirty="0"/>
+          </a:p>
+        </p:txBody>
+      </p:sp>
+      <p:sp>
+        <p:nvSpPr>
+          <p:cNvPr id="26" name="Text 24"/>
+          <p:cNvSpPr/>
+          <p:nvPr/>
+        </p:nvSpPr>
+        <p:spPr>
+          <a:xfrm>
+            <a:off x="685800" y="5742432"/>
+            <a:ext cx="3337560" cy="274320"/>
+          </a:xfrm>
+          <a:prstGeom prst="rect">
+            <a:avLst/>
+          </a:prstGeom>
+          <a:noFill/>
+          <a:ln/>
+        </p:spPr>
+        <p:txBody>
+          <a:bodyPr wrap="square" lIns="0" tIns="0" rIns="0" bIns="0" rtlCol="0" anchor="ctr">
+            <a:normAutofit/>
+          </a:bodyPr>
           <a:lstStyle/>
           <a:p>
             <a:pPr indent="0" marL="0">
               <a:buNone/>
             </a:pPr>
             <a:r>
-              <a:rPr lang="en-US" sz="750" dirty="0">
+              <a:rPr lang="en-US" sz="1050" dirty="0">
                 <a:solidFill>
                   <a:srgbClr val="60706B"/>
                 </a:solidFill>
@@ -6964,6 +7006,294 @@
                 <a:ea typeface="Aptos" pitchFamily="34" charset="-122"/>
                 <a:cs typeface="Aptos" pitchFamily="34" charset="-120"/>
               </a:rPr>
+              <a:t>Android e front-end</a:t>
+            </a:r>
+            <a:endParaRPr lang="en-US" sz="1050" dirty="0"/>
+          </a:p>
+        </p:txBody>
+      </p:sp>
+      <p:sp>
+        <p:nvSpPr>
+          <p:cNvPr id="27" name="Shape 25"/>
+          <p:cNvSpPr/>
+          <p:nvPr/>
+        </p:nvSpPr>
+        <p:spPr>
+          <a:xfrm>
+            <a:off x="4462272" y="5321808"/>
+            <a:ext cx="3337560" cy="0"/>
+          </a:xfrm>
+          <a:prstGeom prst="line">
+            <a:avLst/>
+          </a:prstGeom>
+          <a:noFill/>
+          <a:ln w="25400">
+            <a:solidFill>
+              <a:srgbClr val="0E604B"/>
+            </a:solidFill>
+            <a:prstDash val="solid"/>
+          </a:ln>
+        </p:spPr>
+      </p:sp>
+      <p:sp>
+        <p:nvSpPr>
+          <p:cNvPr id="28" name="Text 26"/>
+          <p:cNvSpPr/>
+          <p:nvPr/>
+        </p:nvSpPr>
+        <p:spPr>
+          <a:xfrm>
+            <a:off x="4462272" y="5468112"/>
+            <a:ext cx="3337560" cy="219456"/>
+          </a:xfrm>
+          <a:prstGeom prst="rect">
+            <a:avLst/>
+          </a:prstGeom>
+          <a:noFill/>
+          <a:ln/>
+        </p:spPr>
+        <p:txBody>
+          <a:bodyPr wrap="square" lIns="0" tIns="0" rIns="0" bIns="0" rtlCol="0" anchor="ctr">
+            <a:normAutofit/>
+          </a:bodyPr>
+          <a:lstStyle/>
+          <a:p>
+            <a:pPr indent="0" marL="0">
+              <a:buNone/>
+            </a:pPr>
+            <a:r>
+              <a:rPr lang="en-US" sz="1300" b="1" dirty="0">
+                <a:solidFill>
+                  <a:srgbClr val="192321"/>
+                </a:solidFill>
+                <a:latin typeface="Aptos Display" pitchFamily="34" charset="0"/>
+                <a:ea typeface="Aptos Display" pitchFamily="34" charset="-122"/>
+                <a:cs typeface="Aptos Display" pitchFamily="34" charset="-120"/>
+              </a:rPr>
+              <a:t>MARCOS PAULO</a:t>
+            </a:r>
+            <a:endParaRPr lang="en-US" sz="1300" dirty="0"/>
+          </a:p>
+        </p:txBody>
+      </p:sp>
+      <p:sp>
+        <p:nvSpPr>
+          <p:cNvPr id="29" name="Text 27"/>
+          <p:cNvSpPr/>
+          <p:nvPr/>
+        </p:nvSpPr>
+        <p:spPr>
+          <a:xfrm>
+            <a:off x="4462272" y="5742432"/>
+            <a:ext cx="3337560" cy="274320"/>
+          </a:xfrm>
+          <a:prstGeom prst="rect">
+            <a:avLst/>
+          </a:prstGeom>
+          <a:noFill/>
+          <a:ln/>
+        </p:spPr>
+        <p:txBody>
+          <a:bodyPr wrap="square" lIns="0" tIns="0" rIns="0" bIns="0" rtlCol="0" anchor="ctr">
+            <a:normAutofit/>
+          </a:bodyPr>
+          <a:lstStyle/>
+          <a:p>
+            <a:pPr indent="0" marL="0">
+              <a:buNone/>
+            </a:pPr>
+            <a:r>
+              <a:rPr lang="en-US" sz="1050" dirty="0">
+                <a:solidFill>
+                  <a:srgbClr val="60706B"/>
+                </a:solidFill>
+                <a:latin typeface="Aptos" pitchFamily="34" charset="0"/>
+                <a:ea typeface="Aptos" pitchFamily="34" charset="-122"/>
+                <a:cs typeface="Aptos" pitchFamily="34" charset="-120"/>
+              </a:rPr>
+              <a:t>Inteligência artificial</a:t>
+            </a:r>
+            <a:endParaRPr lang="en-US" sz="1050" dirty="0"/>
+          </a:p>
+        </p:txBody>
+      </p:sp>
+      <p:sp>
+        <p:nvSpPr>
+          <p:cNvPr id="30" name="Shape 28"/>
+          <p:cNvSpPr/>
+          <p:nvPr/>
+        </p:nvSpPr>
+        <p:spPr>
+          <a:xfrm>
+            <a:off x="8238744" y="5321808"/>
+            <a:ext cx="3337560" cy="0"/>
+          </a:xfrm>
+          <a:prstGeom prst="line">
+            <a:avLst/>
+          </a:prstGeom>
+          <a:noFill/>
+          <a:ln w="25400">
+            <a:solidFill>
+              <a:srgbClr val="F06B4F"/>
+            </a:solidFill>
+            <a:prstDash val="solid"/>
+          </a:ln>
+        </p:spPr>
+      </p:sp>
+      <p:sp>
+        <p:nvSpPr>
+          <p:cNvPr id="31" name="Text 29"/>
+          <p:cNvSpPr/>
+          <p:nvPr/>
+        </p:nvSpPr>
+        <p:spPr>
+          <a:xfrm>
+            <a:off x="8238744" y="5468112"/>
+            <a:ext cx="3337560" cy="219456"/>
+          </a:xfrm>
+          <a:prstGeom prst="rect">
+            <a:avLst/>
+          </a:prstGeom>
+          <a:noFill/>
+          <a:ln/>
+        </p:spPr>
+        <p:txBody>
+          <a:bodyPr wrap="square" lIns="0" tIns="0" rIns="0" bIns="0" rtlCol="0" anchor="ctr">
+            <a:normAutofit/>
+          </a:bodyPr>
+          <a:lstStyle/>
+          <a:p>
+            <a:pPr indent="0" marL="0">
+              <a:buNone/>
+            </a:pPr>
+            <a:r>
+              <a:rPr lang="en-US" sz="1300" b="1" dirty="0">
+                <a:solidFill>
+                  <a:srgbClr val="192321"/>
+                </a:solidFill>
+                <a:latin typeface="Aptos Display" pitchFamily="34" charset="0"/>
+                <a:ea typeface="Aptos Display" pitchFamily="34" charset="-122"/>
+                <a:cs typeface="Aptos Display" pitchFamily="34" charset="-120"/>
+              </a:rPr>
+              <a:t>LUCAS ISAAC</a:t>
+            </a:r>
+            <a:endParaRPr lang="en-US" sz="1300" dirty="0"/>
+          </a:p>
+        </p:txBody>
+      </p:sp>
+      <p:sp>
+        <p:nvSpPr>
+          <p:cNvPr id="32" name="Text 30"/>
+          <p:cNvSpPr/>
+          <p:nvPr/>
+        </p:nvSpPr>
+        <p:spPr>
+          <a:xfrm>
+            <a:off x="8238744" y="5742432"/>
+            <a:ext cx="3337560" cy="274320"/>
+          </a:xfrm>
+          <a:prstGeom prst="rect">
+            <a:avLst/>
+          </a:prstGeom>
+          <a:noFill/>
+          <a:ln/>
+        </p:spPr>
+        <p:txBody>
+          <a:bodyPr wrap="square" lIns="0" tIns="0" rIns="0" bIns="0" rtlCol="0" anchor="ctr">
+            <a:normAutofit/>
+          </a:bodyPr>
+          <a:lstStyle/>
+          <a:p>
+            <a:pPr indent="0" marL="0">
+              <a:buNone/>
+            </a:pPr>
+            <a:r>
+              <a:rPr lang="en-US" sz="1050" dirty="0">
+                <a:solidFill>
+                  <a:srgbClr val="60706B"/>
+                </a:solidFill>
+                <a:latin typeface="Aptos" pitchFamily="34" charset="0"/>
+                <a:ea typeface="Aptos" pitchFamily="34" charset="-122"/>
+                <a:cs typeface="Aptos" pitchFamily="34" charset="-120"/>
+              </a:rPr>
+              <a:t>Inteligência artificial, privacidade e requisitos</a:t>
+            </a:r>
+            <a:endParaRPr lang="en-US" sz="1050" dirty="0"/>
+          </a:p>
+        </p:txBody>
+      </p:sp>
+      <p:sp>
+        <p:nvSpPr>
+          <p:cNvPr id="33" name="Text 31"/>
+          <p:cNvSpPr/>
+          <p:nvPr/>
+        </p:nvSpPr>
+        <p:spPr>
+          <a:xfrm>
+            <a:off x="2971800" y="6099048"/>
+            <a:ext cx="6263640" cy="228600"/>
+          </a:xfrm>
+          <a:prstGeom prst="rect">
+            <a:avLst/>
+          </a:prstGeom>
+          <a:noFill/>
+          <a:ln/>
+        </p:spPr>
+        <p:txBody>
+          <a:bodyPr wrap="square" lIns="0" tIns="0" rIns="0" bIns="0" rtlCol="0" anchor="ctr"/>
+          <a:lstStyle/>
+          <a:p>
+            <a:pPr algn="ctr" indent="0" marL="0">
+              <a:buNone/>
+            </a:pPr>
+            <a:r>
+              <a:rPr lang="en-US" sz="1500" b="1" dirty="0">
+                <a:solidFill>
+                  <a:srgbClr val="0E604B"/>
+                </a:solidFill>
+                <a:latin typeface="Aptos Display" pitchFamily="34" charset="0"/>
+                <a:ea typeface="Aptos Display" pitchFamily="34" charset="-122"/>
+                <a:cs typeface="Aptos Display" pitchFamily="34" charset="-120"/>
+              </a:rPr>
+              <a:t>Devolver ao médico tempo e atenção para o paciente.</a:t>
+            </a:r>
+            <a:endParaRPr lang="en-US" sz="1500" dirty="0"/>
+          </a:p>
+        </p:txBody>
+      </p:sp>
+      <p:sp>
+        <p:nvSpPr>
+          <p:cNvPr id="34" name="Text 32"/>
+          <p:cNvSpPr/>
+          <p:nvPr/>
+        </p:nvSpPr>
+        <p:spPr>
+          <a:xfrm>
+            <a:off x="594360" y="6428232"/>
+            <a:ext cx="5394960" cy="164592"/>
+          </a:xfrm>
+          <a:prstGeom prst="rect">
+            <a:avLst/>
+          </a:prstGeom>
+          <a:noFill/>
+          <a:ln/>
+        </p:spPr>
+        <p:txBody>
+          <a:bodyPr wrap="square" lIns="0" tIns="0" rIns="0" bIns="0" rtlCol="0" anchor="ctr"/>
+          <a:lstStyle/>
+          <a:p>
+            <a:pPr indent="0" marL="0">
+              <a:buNone/>
+            </a:pPr>
+            <a:r>
+              <a:rPr lang="en-US" sz="750" dirty="0">
+                <a:solidFill>
+                  <a:srgbClr val="60706B"/>
+                </a:solidFill>
+                <a:latin typeface="Aptos" pitchFamily="34" charset="0"/>
+                <a:ea typeface="Aptos" pitchFamily="34" charset="-122"/>
+                <a:cs typeface="Aptos" pitchFamily="34" charset="-120"/>
+              </a:rPr>
               <a:t>Assistente de Prontuário Automático · AI Glasses Brasil 2026</a:t>
             </a:r>
             <a:endParaRPr lang="en-US" sz="750" dirty="0"/>
@@ -6972,7 +7302,7 @@
       </p:sp>
       <p:sp>
         <p:nvSpPr>
-          <p:cNvPr id="26" name="Text 24">
+          <p:cNvPr id="35" name="Text 33">
             <a:hlinkClick r:id="rId1" tooltip=""/>
           </p:cNvPr>
           <p:cNvSpPr/>

</xml_diff>

<commit_message>
feat(brand): introduce Medware identity
Create a brand-first pitch cover, apply the Medware name across public documentation and Android UI, and regenerate the PDF, previews, and Canva assets.
</commit_message>
<xml_diff>
--- a/docs/entrega/pitch/PITCH_AI_GLASSES_BRASIL.pptx
+++ b/docs/entrega/pitch/PITCH_AI_GLASSES_BRASIL.pptx
@@ -507,7 +507,8 @@
           <a:p>
             <a:r>
               <a:rPr lang="en-US" dirty="0"/>
-              <a:t>Uma consulta deveria ser uma conversa entre médico e paciente.
+              <a:t>Nós somos a Medware.
+Nossa proposta é simples: a consulta fica com o médico; o registro, com a inteligência.
 Mas o médico precisa escutar, raciocinar e documentar ao mesmo tempo.
 Essa disputa reduz o contato visual e frequentemente estende o trabalho para depois do atendimento.</a:t>
             </a:r>
@@ -687,7 +688,7 @@
           <a:p>
             <a:r>
               <a:rPr lang="en-US" dirty="0"/>
-              <a:t>Nossa proposta é um assistente de prontuário automático para Ray-Ban Meta.
+              <a:t>A Medware é um assistente de prontuário automático para Ray-Ban Meta.
 O médico conduz a consulta sem tocar em telas.
 O áudio é processado localmente no Android, fotos e atestados podem ser solicitados por voz e, ao final, o médico recebe um rascunho para revisar.
 A inteligência artificial prepara; o médico decide.</a:t>
@@ -1555,8 +1556,47 @@
         </p:nvSpPr>
         <p:spPr>
           <a:xfrm>
-            <a:off x="658368" y="658368"/>
-            <a:ext cx="5120640" cy="1325880"/>
+            <a:off x="685800" y="438912"/>
+            <a:ext cx="4480560" cy="219456"/>
+          </a:xfrm>
+          <a:prstGeom prst="rect">
+            <a:avLst/>
+          </a:prstGeom>
+          <a:noFill/>
+          <a:ln/>
+        </p:spPr>
+        <p:txBody>
+          <a:bodyPr wrap="square" lIns="0" tIns="0" rIns="0" bIns="0" rtlCol="0" anchor="ctr"/>
+          <a:lstStyle/>
+          <a:p>
+            <a:pPr indent="0" marL="0">
+              <a:buNone/>
+            </a:pPr>
+            <a:r>
+              <a:rPr lang="en-US" sz="950" b="1" spc="150" kern="0" dirty="0">
+                <a:solidFill>
+                  <a:srgbClr val="A9B8B2"/>
+                </a:solidFill>
+                <a:latin typeface="Aptos" pitchFamily="34" charset="0"/>
+                <a:ea typeface="Aptos" pitchFamily="34" charset="-122"/>
+                <a:cs typeface="Aptos" pitchFamily="34" charset="-120"/>
+              </a:rPr>
+              <a:t>AI GLASSES BRASIL 2026  ·  BEM-ESTAR</a:t>
+            </a:r>
+            <a:endParaRPr lang="en-US" sz="950" dirty="0"/>
+          </a:p>
+        </p:txBody>
+      </p:sp>
+      <p:sp>
+        <p:nvSpPr>
+          <p:cNvPr id="5" name="Text 2"/>
+          <p:cNvSpPr/>
+          <p:nvPr/>
+        </p:nvSpPr>
+        <p:spPr>
+          <a:xfrm>
+            <a:off x="658368" y="804672"/>
+            <a:ext cx="4480560" cy="713232"/>
           </a:xfrm>
           <a:prstGeom prst="rect">
             <a:avLst/>
@@ -1574,7 +1614,7 @@
               <a:buNone/>
             </a:pPr>
             <a:r>
-              <a:rPr lang="en-US" sz="2900" b="1" dirty="0">
+              <a:rPr lang="en-US" sz="4300" b="1" dirty="0">
                 <a:solidFill>
                   <a:srgbClr val="FFFFFF"/>
                 </a:solidFill>
@@ -1582,55 +1622,135 @@
                 <a:ea typeface="Aptos Display" pitchFamily="34" charset="-122"/>
                 <a:cs typeface="Aptos Display" pitchFamily="34" charset="-120"/>
               </a:rPr>
-              <a:t>O PRONTUÁRIO DISPUTA</a:t>
-            </a:r>
-            <a:endParaRPr lang="en-US" sz="2900" dirty="0"/>
-          </a:p>
-          <a:p>
+              <a:t>MED</a:t>
+            </a:r>
             <a:pPr indent="0" marL="0">
               <a:buNone/>
             </a:pPr>
             <a:r>
-              <a:rPr lang="en-US" sz="2900" b="1" dirty="0">
-                <a:solidFill>
-                  <a:srgbClr val="FFFFFF"/>
+              <a:rPr lang="en-US" sz="4300" b="1" dirty="0">
+                <a:solidFill>
+                  <a:srgbClr val="C8E662"/>
                 </a:solidFill>
                 <a:latin typeface="Aptos Display" pitchFamily="34" charset="0"/>
                 <a:ea typeface="Aptos Display" pitchFamily="34" charset="-122"/>
                 <a:cs typeface="Aptos Display" pitchFamily="34" charset="-120"/>
               </a:rPr>
-              <a:t>ATENÇÃO COM O PACIENTE</a:t>
-            </a:r>
-            <a:endParaRPr lang="en-US" sz="2900" dirty="0"/>
-          </a:p>
-        </p:txBody>
-      </p:sp>
-      <p:sp>
-        <p:nvSpPr>
-          <p:cNvPr id="5" name="Text 2"/>
-          <p:cNvSpPr/>
-          <p:nvPr/>
-        </p:nvSpPr>
-        <p:spPr>
-          <a:xfrm>
-            <a:off x="685800" y="2148840"/>
-            <a:ext cx="4434840" cy="594360"/>
-          </a:xfrm>
-          <a:prstGeom prst="rect">
-            <a:avLst/>
-          </a:prstGeom>
-          <a:noFill/>
-          <a:ln/>
-        </p:spPr>
-        <p:txBody>
-          <a:bodyPr wrap="square" lIns="0" tIns="0" rIns="0" bIns="0" rtlCol="0" anchor="ctr"/>
+              <a:t>WARE</a:t>
+            </a:r>
+            <a:endParaRPr lang="en-US" sz="4300" dirty="0"/>
+          </a:p>
+        </p:txBody>
+      </p:sp>
+      <p:sp>
+        <p:nvSpPr>
+          <p:cNvPr id="6" name="Shape 3"/>
+          <p:cNvSpPr/>
+          <p:nvPr/>
+        </p:nvSpPr>
+        <p:spPr>
+          <a:xfrm>
+            <a:off x="685800" y="1627632"/>
+            <a:ext cx="786384" cy="0"/>
+          </a:xfrm>
+          <a:prstGeom prst="line">
+            <a:avLst/>
+          </a:prstGeom>
+          <a:noFill/>
+          <a:ln w="50800">
+            <a:solidFill>
+              <a:srgbClr val="F06B4F"/>
+            </a:solidFill>
+            <a:prstDash val="solid"/>
+          </a:ln>
+        </p:spPr>
+      </p:sp>
+      <p:sp>
+        <p:nvSpPr>
+          <p:cNvPr id="7" name="Text 4"/>
+          <p:cNvSpPr/>
+          <p:nvPr/>
+        </p:nvSpPr>
+        <p:spPr>
+          <a:xfrm>
+            <a:off x="685800" y="1901952"/>
+            <a:ext cx="4526280" cy="868680"/>
+          </a:xfrm>
+          <a:prstGeom prst="rect">
+            <a:avLst/>
+          </a:prstGeom>
+          <a:noFill/>
+          <a:ln/>
+        </p:spPr>
+        <p:txBody>
+          <a:bodyPr wrap="square" lIns="0" tIns="0" rIns="0" bIns="0" rtlCol="0" anchor="ctr">
+            <a:normAutofit/>
+          </a:bodyPr>
           <a:lstStyle/>
           <a:p>
             <a:pPr indent="0" marL="0">
               <a:buNone/>
             </a:pPr>
             <a:r>
-              <a:rPr lang="en-US" sz="1700" dirty="0">
+              <a:rPr lang="en-US" sz="2300" b="1" dirty="0">
+                <a:solidFill>
+                  <a:srgbClr val="FFFFFF"/>
+                </a:solidFill>
+                <a:latin typeface="Aptos Display" pitchFamily="34" charset="0"/>
+                <a:ea typeface="Aptos Display" pitchFamily="34" charset="-122"/>
+                <a:cs typeface="Aptos Display" pitchFamily="34" charset="-120"/>
+              </a:rPr>
+              <a:t>A consulta fica com o médico.</a:t>
+            </a:r>
+            <a:endParaRPr lang="en-US" sz="2300" dirty="0"/>
+          </a:p>
+          <a:p>
+            <a:pPr indent="0" marL="0">
+              <a:buNone/>
+            </a:pPr>
+            <a:r>
+              <a:rPr lang="en-US" sz="2300" b="1" dirty="0">
+                <a:solidFill>
+                  <a:srgbClr val="FFFFFF"/>
+                </a:solidFill>
+                <a:latin typeface="Aptos Display" pitchFamily="34" charset="0"/>
+                <a:ea typeface="Aptos Display" pitchFamily="34" charset="-122"/>
+                <a:cs typeface="Aptos Display" pitchFamily="34" charset="-120"/>
+              </a:rPr>
+              <a:t>O registro, com a inteligência.</a:t>
+            </a:r>
+            <a:endParaRPr lang="en-US" sz="2300" dirty="0"/>
+          </a:p>
+        </p:txBody>
+      </p:sp>
+      <p:sp>
+        <p:nvSpPr>
+          <p:cNvPr id="8" name="Text 5"/>
+          <p:cNvSpPr/>
+          <p:nvPr/>
+        </p:nvSpPr>
+        <p:spPr>
+          <a:xfrm>
+            <a:off x="685800" y="2971800"/>
+            <a:ext cx="4343400" cy="640080"/>
+          </a:xfrm>
+          <a:prstGeom prst="rect">
+            <a:avLst/>
+          </a:prstGeom>
+          <a:noFill/>
+          <a:ln/>
+        </p:spPr>
+        <p:txBody>
+          <a:bodyPr wrap="square" lIns="0" tIns="0" rIns="0" bIns="0" rtlCol="0" anchor="ctr">
+            <a:normAutofit/>
+          </a:bodyPr>
+          <a:lstStyle/>
+          <a:p>
+            <a:pPr indent="0" marL="0">
+              <a:buNone/>
+            </a:pPr>
+            <a:r>
+              <a:rPr lang="en-US" sz="1450" dirty="0">
                 <a:solidFill>
                   <a:srgbClr val="D5E1DC"/>
                 </a:solidFill>
@@ -1638,45 +1758,22 @@
                 <a:ea typeface="Aptos" pitchFamily="34" charset="-122"/>
                 <a:cs typeface="Aptos" pitchFamily="34" charset="-120"/>
               </a:rPr>
-              <a:t>Escutar, raciocinar e documentar — ao mesmo tempo.</a:t>
-            </a:r>
-            <a:endParaRPr lang="en-US" sz="1700" dirty="0"/>
-          </a:p>
-        </p:txBody>
-      </p:sp>
-      <p:sp>
-        <p:nvSpPr>
-          <p:cNvPr id="6" name="Shape 3"/>
-          <p:cNvSpPr/>
-          <p:nvPr/>
-        </p:nvSpPr>
-        <p:spPr>
-          <a:xfrm>
-            <a:off x="685800" y="2971800"/>
-            <a:ext cx="4297680" cy="0"/>
-          </a:xfrm>
-          <a:prstGeom prst="line">
-            <a:avLst/>
-          </a:prstGeom>
-          <a:noFill/>
-          <a:ln w="25400">
-            <a:solidFill>
-              <a:srgbClr val="C8E662"/>
-            </a:solidFill>
-            <a:prstDash val="solid"/>
-          </a:ln>
-        </p:spPr>
-      </p:sp>
-      <p:sp>
-        <p:nvSpPr>
-          <p:cNvPr id="7" name="Text 4"/>
-          <p:cNvSpPr/>
-          <p:nvPr/>
-        </p:nvSpPr>
-        <p:spPr>
-          <a:xfrm>
-            <a:off x="685800" y="3310128"/>
-            <a:ext cx="685800" cy="274320"/>
+              <a:t>Um assistente clínico mãos livres que transforma a consulta em rascunho de prontuário para revisão médica.</a:t>
+            </a:r>
+            <a:endParaRPr lang="en-US" sz="1450" dirty="0"/>
+          </a:p>
+        </p:txBody>
+      </p:sp>
+      <p:sp>
+        <p:nvSpPr>
+          <p:cNvPr id="9" name="Text 6"/>
+          <p:cNvSpPr/>
+          <p:nvPr/>
+        </p:nvSpPr>
+        <p:spPr>
+          <a:xfrm>
+            <a:off x="685800" y="3858768"/>
+            <a:ext cx="1645920" cy="228600"/>
           </a:xfrm>
           <a:prstGeom prst="rect">
             <a:avLst/>
@@ -1692,7 +1789,7 @@
               <a:buNone/>
             </a:pPr>
             <a:r>
-              <a:rPr lang="en-US" sz="1200" b="1" dirty="0">
+              <a:rPr lang="en-US" sz="1200" b="1" spc="120" kern="0" dirty="0">
                 <a:solidFill>
                   <a:srgbClr val="C8E662"/>
                 </a:solidFill>
@@ -1700,7 +1797,7 @@
                 <a:ea typeface="Aptos" pitchFamily="34" charset="-122"/>
                 <a:cs typeface="Aptos" pitchFamily="34" charset="-120"/>
               </a:rPr>
-              <a:t>ATÉ</a:t>
+              <a:t>O PROBLEMA</a:t>
             </a:r>
             <a:endParaRPr lang="en-US" sz="1200" dirty="0"/>
           </a:p>
@@ -1708,14 +1805,14 @@
       </p:sp>
       <p:sp>
         <p:nvSpPr>
-          <p:cNvPr id="8" name="Text 5"/>
-          <p:cNvSpPr/>
-          <p:nvPr/>
-        </p:nvSpPr>
-        <p:spPr>
-          <a:xfrm>
-            <a:off x="685800" y="3611880"/>
-            <a:ext cx="1143000" cy="841248"/>
+          <p:cNvPr id="10" name="Text 7"/>
+          <p:cNvSpPr/>
+          <p:nvPr/>
+        </p:nvSpPr>
+        <p:spPr>
+          <a:xfrm>
+            <a:off x="685800" y="4224528"/>
+            <a:ext cx="1188720" cy="777240"/>
           </a:xfrm>
           <a:prstGeom prst="rect">
             <a:avLst/>
@@ -1731,7 +1828,7 @@
               <a:buNone/>
             </a:pPr>
             <a:r>
-              <a:rPr lang="en-US" sz="4900" b="1" dirty="0">
+              <a:rPr lang="en-US" sz="4600" b="1" dirty="0">
                 <a:solidFill>
                   <a:srgbClr val="FFFFFF"/>
                 </a:solidFill>
@@ -1741,20 +1838,20 @@
               </a:rPr>
               <a:t>2h</a:t>
             </a:r>
-            <a:endParaRPr lang="en-US" sz="4900" dirty="0"/>
-          </a:p>
-        </p:txBody>
-      </p:sp>
-      <p:sp>
-        <p:nvSpPr>
-          <p:cNvPr id="9" name="Text 6"/>
-          <p:cNvSpPr/>
-          <p:nvPr/>
-        </p:nvSpPr>
-        <p:spPr>
-          <a:xfrm>
-            <a:off x="1874520" y="3703320"/>
-            <a:ext cx="3017520" cy="658368"/>
+            <a:endParaRPr lang="en-US" sz="4600" dirty="0"/>
+          </a:p>
+        </p:txBody>
+      </p:sp>
+      <p:sp>
+        <p:nvSpPr>
+          <p:cNvPr id="11" name="Text 8"/>
+          <p:cNvSpPr/>
+          <p:nvPr/>
+        </p:nvSpPr>
+        <p:spPr>
+          <a:xfrm>
+            <a:off x="1847088" y="4297680"/>
+            <a:ext cx="3154680" cy="594360"/>
           </a:xfrm>
           <a:prstGeom prst="rect">
             <a:avLst/>
@@ -1770,7 +1867,7 @@
               <a:buNone/>
             </a:pPr>
             <a:r>
-              <a:rPr lang="en-US" sz="1400" dirty="0">
+              <a:rPr lang="en-US" sz="1350" dirty="0">
                 <a:solidFill>
                   <a:srgbClr val="FFFFFF"/>
                 </a:solidFill>
@@ -1780,14 +1877,14 @@
               </a:rPr>
               <a:t>de prontuário e tarefas administrativas</a:t>
             </a:r>
-            <a:endParaRPr lang="en-US" sz="1400" dirty="0"/>
+            <a:endParaRPr lang="en-US" sz="1350" dirty="0"/>
           </a:p>
           <a:p>
             <a:pPr indent="0" marL="0">
               <a:buNone/>
             </a:pPr>
             <a:r>
-              <a:rPr lang="en-US" sz="1400" dirty="0">
+              <a:rPr lang="en-US" sz="1350" dirty="0">
                 <a:solidFill>
                   <a:srgbClr val="FFFFFF"/>
                 </a:solidFill>
@@ -1797,20 +1894,20 @@
               </a:rPr>
               <a:t>para cada 1h de atendimento clínico</a:t>
             </a:r>
-            <a:endParaRPr lang="en-US" sz="1400" dirty="0"/>
-          </a:p>
-        </p:txBody>
-      </p:sp>
-      <p:sp>
-        <p:nvSpPr>
-          <p:cNvPr id="10" name="Text 7"/>
-          <p:cNvSpPr/>
-          <p:nvPr/>
-        </p:nvSpPr>
-        <p:spPr>
-          <a:xfrm>
-            <a:off x="694944" y="4590288"/>
-            <a:ext cx="4389120" cy="256032"/>
+            <a:endParaRPr lang="en-US" sz="1350" dirty="0"/>
+          </a:p>
+        </p:txBody>
+      </p:sp>
+      <p:sp>
+        <p:nvSpPr>
+          <p:cNvPr id="12" name="Text 9"/>
+          <p:cNvSpPr/>
+          <p:nvPr/>
+        </p:nvSpPr>
+        <p:spPr>
+          <a:xfrm>
+            <a:off x="694944" y="5138928"/>
+            <a:ext cx="4389120" cy="219456"/>
           </a:xfrm>
           <a:prstGeom prst="rect">
             <a:avLst/>
@@ -1842,14 +1939,14 @@
       </p:sp>
       <p:sp>
         <p:nvSpPr>
-          <p:cNvPr id="11" name="Text 8"/>
+          <p:cNvPr id="13" name="Text 10"/>
           <p:cNvSpPr/>
           <p:nvPr/>
         </p:nvSpPr>
         <p:spPr>
           <a:xfrm>
             <a:off x="685800" y="6181344"/>
-            <a:ext cx="4206240" cy="228600"/>
+            <a:ext cx="4480560" cy="228600"/>
           </a:xfrm>
           <a:prstGeom prst="rect">
             <a:avLst/>
@@ -1865,7 +1962,7 @@
               <a:buNone/>
             </a:pPr>
             <a:r>
-              <a:rPr lang="en-US" sz="900" b="1" dirty="0">
+              <a:rPr lang="en-US" sz="850" b="1" spc="80" kern="0" dirty="0">
                 <a:solidFill>
                   <a:srgbClr val="FFFFFF"/>
                 </a:solidFill>
@@ -1873,15 +1970,15 @@
                 <a:ea typeface="Aptos" pitchFamily="34" charset="-122"/>
                 <a:cs typeface="Aptos" pitchFamily="34" charset="-120"/>
               </a:rPr>
-              <a:t>Assistente de Prontuário Automático</a:t>
-            </a:r>
-            <a:endParaRPr lang="en-US" sz="900" dirty="0"/>
-          </a:p>
-        </p:txBody>
-      </p:sp>
-      <p:sp>
-        <p:nvSpPr>
-          <p:cNvPr id="12" name="Text 9">
+              <a:t>MEDWARE  ·  ASSISTENTE DE PRONTUÁRIO AUTOMÁTICO</a:t>
+            </a:r>
+            <a:endParaRPr lang="en-US" sz="850" dirty="0"/>
+          </a:p>
+        </p:txBody>
+      </p:sp>
+      <p:sp>
+        <p:nvSpPr>
+          <p:cNvPr id="14" name="Text 11">
             <a:hlinkClick r:id="rId2" tooltip=""/>
           </p:cNvPr>
           <p:cNvSpPr/>
@@ -2676,7 +2773,7 @@
                 <a:ea typeface="Aptos" pitchFamily="34" charset="-122"/>
                 <a:cs typeface="Aptos" pitchFamily="34" charset="-120"/>
               </a:rPr>
-              <a:t>Assistente de Prontuário Automático · AI Glasses Brasil 2026</a:t>
+              <a:t>Medware · AI Glasses Brasil 2026</a:t>
             </a:r>
             <a:endParaRPr lang="en-US" sz="750" dirty="0"/>
           </a:p>
@@ -3545,7 +3642,7 @@
                 <a:ea typeface="Aptos" pitchFamily="34" charset="-122"/>
                 <a:cs typeface="Aptos" pitchFamily="34" charset="-120"/>
               </a:rPr>
-              <a:t>Assistente de Prontuário Automático · AI Glasses Brasil 2026</a:t>
+              <a:t>Medware · AI Glasses Brasil 2026</a:t>
             </a:r>
             <a:endParaRPr lang="en-US" sz="750" dirty="0"/>
           </a:p>
@@ -4833,7 +4930,7 @@
                 <a:ea typeface="Aptos" pitchFamily="34" charset="-122"/>
                 <a:cs typeface="Aptos" pitchFamily="34" charset="-120"/>
               </a:rPr>
-              <a:t>Assistente de Prontuário Automático · AI Glasses Brasil 2026</a:t>
+              <a:t>Medware · AI Glasses Brasil 2026</a:t>
             </a:r>
             <a:endParaRPr lang="en-US" sz="750" dirty="0"/>
           </a:p>
@@ -7294,7 +7391,7 @@
                 <a:ea typeface="Aptos" pitchFamily="34" charset="-122"/>
                 <a:cs typeface="Aptos" pitchFamily="34" charset="-120"/>
               </a:rPr>
-              <a:t>Assistente de Prontuário Automático · AI Glasses Brasil 2026</a:t>
+              <a:t>Medware · AI Glasses Brasil 2026</a:t>
             </a:r>
             <a:endParaRPr lang="en-US" sz="750" dirty="0"/>
           </a:p>

</xml_diff>

<commit_message>
docs(pitch): add detailed three-minute speaker script
Document the purpose, delivery, transitions, cautions, and likely Q&A for every slide, and embed the 384-word timed script in the PowerPoint presenter notes.
</commit_message>
<xml_diff>
--- a/docs/entrega/pitch/PITCH_AI_GLASSES_BRASIL.pptx
+++ b/docs/entrega/pitch/PITCH_AI_GLASSES_BRASIL.pptx
@@ -507,10 +507,10 @@
           <a:p>
             <a:r>
               <a:rPr lang="en-US" dirty="0"/>
-              <a:t>Nós somos a Medware.
-Nossa proposta é simples: a consulta fica com o médico; o registro, com a inteligência.
-Mas o médico precisa escutar, raciocinar e documentar ao mesmo tempo.
-Essa disputa reduz o contato visual e frequentemente estende o trabalho para depois do atendimento.</a:t>
+              <a:t>[0:00–0:25]
+Nós somos a Medware. Nossa proposta é simples: a consulta fica com o médico; o registro, com a inteligência.
+Um estudo publicado por Sinsky e colaboradores observou cerca de duas horas de prontuário e tarefas administrativas para cada hora de atendimento clínico.
+Queremos enfrentar essa disputa por atenção com um assistente clínico mãos livres.</a:t>
             </a:r>
             <a:endParaRPr lang="en-US" dirty="0"/>
           </a:p>
@@ -598,9 +598,10 @@
           <a:p>
             <a:r>
               <a:rPr lang="en-US" dirty="0"/>
-              <a:t>Não queríamos assumir que um estudo internacional representava a rotina brasileira.
-O Dr. Ranieri resumiu a tensão central: o prontuário deveria registrar a consulta, não interrompê-la.
-A próxima rodada de entrevistas mede tempo, contato visual, confiança e os principais receios.</a:t>
+              <a:t>[0:25–0:45]
+Na nossa escuta inicial, o Dr. Ranieri resumiu bem o problema: “O prontuário deveria registrar a consulta, não interrompê-la.”
+Essa fala orientou nossas perguntas sobre tempo, contato visual e confiança.
+Agora, a validação deve medir quatro eixos: precisão, privacidade, revisão médica e bateria.</a:t>
             </a:r>
             <a:endParaRPr lang="en-US" dirty="0"/>
           </a:p>
@@ -688,10 +689,11 @@
           <a:p>
             <a:r>
               <a:rPr lang="en-US" dirty="0"/>
-              <a:t>A Medware é um assistente de prontuário automático para Ray-Ban Meta.
-O médico conduz a consulta sem tocar em telas.
-O áudio é processado localmente no Android, fotos e atestados podem ser solicitados por voz e, ao final, o médico recebe um rascunho para revisar.
-A inteligência artificial prepara; o médico decide.</a:t>
+              <a:t>[0:45–1:10]
+A Medware permite que o médico conduza a consulta sem alternar continuamente para uma tela.
+O áudio é processado localmente no Android, e comandos de voz permitem registrar uma foto ou preparar um atestado.
+Ao final, o médico recebe um rascunho clínico para editar, confirmar ou descartar.
+A inteligência prepara; o médico decide.</a:t>
             </a:r>
             <a:endParaRPr lang="en-US" dirty="0"/>
           </a:p>
@@ -779,11 +781,12 @@
           <a:p>
             <a:r>
               <a:rPr lang="en-US" dirty="0"/>
-              <a:t>Antes de começar, o paciente é informado e registra o consentimento.
-Durante a consulta, o microfone dos óculos envia o áudio ao Android por HFP.
-Ao dizer registrar imagem, o DAT captura uma foto pontual e responde imagem registrada.
-Ao encerrar, a IA organiza apenas fatos presentes na transcrição.
-Em nosso teste, o ASR errou um CID e o sistema corretamente o omitiu.</a:t>
+              <a:t>[1:10–1:45]
+O fluxo começa pelo consentimento. Depois, médico e paciente conversam normalmente, e somente o conteúdo autorizado entra no sistema.
+Por voz, o médico pode solicitar uma foto ou um rascunho de atestado.
+No Android, a Medware organiza fatos clínicos e preserva a origem de cada informação.
+Por fim, o médico revisa, corrige e confirma.
+Se a transcrição falhar em um código clínico, o sistema omite o dado em vez de inventar.</a:t>
             </a:r>
             <a:endParaRPr lang="en-US" dirty="0"/>
           </a:p>
@@ -871,10 +874,12 @@
           <a:p>
             <a:r>
               <a:rPr lang="en-US" dirty="0"/>
-              <a:t>O DAT 0.9 controla a câmera, enquanto o áudio usa o caminho HFP documentado pela Meta.
-No telefone, o Vosk transcreve e o pipeline organiza os fatos sem gerar informação nova.
-As respostas voltam por TTS.
-Se alguma camada falha, o sistema degrada função antes de perder a consulta.</a:t>
+              <a:t>[1:45–2:25]
+Os óculos fornecem áudio, câmera e interação mãos livres. No Android, o Vosk transcreve localmente, e o pipeline organiza fatos com origem verificável.
+O médico revisa o resultado, e as confirmações retornam por voz.
+O áudio usa o perfil Bluetooth de chamadas; a câmera usa o toolkit da Meta.
+O conteúdo clínico não é enviado intencionalmente para inteligência em nuvem.
+Se uma camada falhar, reduzimos a automação: preservamos o áudio, usamos o microfone do telefone ou marcamos a informação como não informada.</a:t>
             </a:r>
             <a:endParaRPr lang="en-US" dirty="0"/>
           </a:p>
@@ -962,11 +967,12 @@
           <a:p>
             <a:r>
               <a:rPr lang="en-US" dirty="0"/>
-              <a:t>Já validamos o pipeline completo no emulador Android: áudio real, transcrição, foto por voz, SOAP, atestado, criptografia e revisão.
-São 52 testes automatizados.
-Nossa equipe reúne Lucas Pacheco em Android e front-end, Marcos Paulo em inteligência artificial e Lucas Isaac em inteligência artificial, privacidade e requisitos.
-No hackathon, nossa primeira hora será dedicada a validar o HFP, a câmera DAT e a autonomia no hardware real.
-Não queremos substituir o julgamento médico. Queremos devolver ao médico tempo e atenção para o paciente.</a:t>
+              <a:t>[2:25–3:00]
+Hoje, temos 52 testes automatizados cobrindo o pipeline executado em emulador: prontuário, foto, atestado, cofre criptográfico e revisão.
+O próximo passo é validar no hardware real a voz pelos óculos, a foto pontual e a autonomia por consulta.
+Nosso diferencial combina processamento clínico local, origem verificável e decisão médica.
+Lucas Pacheco lidera Android e front-end; Marcos Paulo, inteligência artificial; e Lucas Isaac, inteligência artificial, privacidade e requisitos.
+A Medware não substitui o médico. Ela devolve tempo e atenção ao paciente.</a:t>
             </a:r>
             <a:endParaRPr lang="en-US" dirty="0"/>
           </a:p>

</xml_diff>